<commit_message>
Finish the pseudocode switch: W02 slide titles, indexes, README
- W02 P14/P22/P25 titles "in Java" -> "on Paper" (deck re-rendered,
  38 pages, 58 SVGs valid, zero Java leftovers)
- Course slide index and W02/W03 STORY design notes no longer name Java
- Repository README: prerequisites for self-learners are now none
- Lab-01 clarifies the PlantUML CLI needs a Java runtime but students
  never write Java themselves
</commit_message>
<xml_diff>
--- a/01-slides/W02-Object-Oriented-Foundations.pptx
+++ b/01-slides/W02-Object-Oriented-Foundations.pptx
@@ -4413,7 +4413,7 @@
   <p:cSld>
     <p:spTree>
       <p:nvGrpSpPr>
-        <p:cNvPr id="120" name="" descr="&lt;Slide style={{ background: '#FFFFFF', padding: 0 }}&gt;&#10;  &lt;Box style={{ height: 72, background: '#1E4FA8', padding: '0 40px', flexDirection: 'row', alignItems: 'center', justifyContent: 'space-between' }}&gt;&#10;    &lt;Text style={{ fontSize: 15, color: '#B9CDF0', letterSpacing: 1 }}&gt;ISAD · INFORMATION SYSTEMS ANALYSIS &amp;amp; DESIGN&lt;/Text&gt;&#10;    &lt;Text style={{ fontSize: 15, color: '#B9CDF0' }}&gt;W02 · ENCAPSULATION&lt;/Text&gt;&#10;  &lt;/Box&gt;&#10;  &lt;Box style={{ padding: '20px 40px 0 40px' }}&gt;&#10;    &lt;Text style={{ fontSize: 32, fontWeight: 'bold', color: '#0E3F8C' }}&gt;Encapsulation in Java&lt;/Text&gt;&#10;  &lt;/Box&gt;&#10;  &lt;Box style={{ flex: 1, padding: '16px 40px 0 40px', flexDirection: 'row', gap: 26 }}&gt;&#10;    &lt;Box style={{ flex: 3, justifyContent: 'center' }}&gt;&#10;      &lt;CodeBlock code={`Class Order&#10;    - lines : OrderLine[0..*]&#10;    - status : OrderStatus = DRAFT&#10;&#10;    + addItem(item, qty)&#10;        if status is not DRAFT&#10;            refuse - order already placed&#10;        lines.add(a new OrderLine(item, qty))&#10;&#10;    + total() : Money&#10;        sum = ZERO&#10;        for each line in lines&#10;            sum = sum + line.subtotal()&#10;        return sum`} language='text' width={580} fontSize={13} /&gt;&#10;    &lt;/Box&gt;&#10;    &lt;Box style={{ flex: 2, flexDirection: 'column', gap: 11, justifyContent: 'center' }}&gt;&#10;      {[&#10;        ['lock', 'private fields', 'Nobody outside can set status to a nonsense value.'],&#10;        ['user-check', 'guarded method', 'addItem() refuses once the order is placed.'],&#10;        ['calculator', 'computed, not stored', 'total() is derived — there is no stale copy to drift.'],&#10;      ].map(([icon, t, d]) =&gt; (&#10;        &lt;Box key={t} style={{ flexDirection: 'row', gap: 12, alignItems: 'flex-start', padding: '14px 16px', background: '#F7F9FC', borderRadius: 10, border: '1px solid #E5E7EB' }}&gt;&#10;          &lt;Box style={{ width: 38, height: 38, borderRadius: 9, background: '#E8EFF8', justifyContent: 'center', alignItems: 'center' }}&gt;&#10;            &lt;FAIcon name={icon} style={{ fill: '#1E4FA8', width: 19, height: 19 }} /&gt;&#10;          &lt;/Box&gt;&#10;          &lt;Box style={{ flex: 1, flexDirection: 'column', gap: 2 }}&gt;&#10;            &lt;Text style={{ fontSize: 16, fontWeight: 'bold', color: '#0E3F8C' }}&gt;{t}&lt;/Text&gt;&#10;            &lt;Text style={{ fontSize: 14, color: '#4A5568', lineHeight: 1.45 }}&gt;{d}&lt;/Text&gt;&#10;          &lt;/Box&gt;&#10;        &lt;/Box&gt;&#10;      ))}&#10;    &lt;/Box&gt;&#10;  &lt;/Box&gt;&#10;  &lt;Box style={{ height: 40, padding: '0 40px', flexDirection: 'row', alignItems: 'center', justifyContent: 'space-between' }}&gt;&#10;    &lt;Text style={{ fontSize: 13, color: '#8B97A8' }}&gt;Generic types omitted for slide width; your lab code uses List&amp;lt;OrderLine&amp;gt;.&lt;/Text&gt;&#10;    &lt;Text style={{ fontSize: 14, color: '#1E4FA8', fontWeight: 'bold' }}&gt;14 / 38&lt;/Text&gt;&#10;  &lt;/Box&gt;&#10;&lt;/Slide&gt;"/>
+        <p:cNvPr id="120" name="" descr="&lt;Slide style={{ background: '#FFFFFF', padding: 0 }}&gt;&#10;  &lt;Box style={{ height: 72, background: '#1E4FA8', padding: '0 40px', flexDirection: 'row', alignItems: 'center', justifyContent: 'space-between' }}&gt;&#10;    &lt;Text style={{ fontSize: 15, color: '#B9CDF0', letterSpacing: 1 }}&gt;ISAD · INFORMATION SYSTEMS ANALYSIS &amp;amp; DESIGN&lt;/Text&gt;&#10;    &lt;Text style={{ fontSize: 15, color: '#B9CDF0' }}&gt;W02 · ENCAPSULATION&lt;/Text&gt;&#10;  &lt;/Box&gt;&#10;  &lt;Box style={{ padding: '20px 40px 0 40px' }}&gt;&#10;    &lt;Text style={{ fontSize: 32, fontWeight: 'bold', color: '#0E3F8C' }}&gt;Encapsulation on Paper&lt;/Text&gt;&#10;  &lt;/Box&gt;&#10;  &lt;Box style={{ flex: 1, padding: '16px 40px 0 40px', flexDirection: 'row', gap: 26 }}&gt;&#10;    &lt;Box style={{ flex: 3, justifyContent: 'center' }}&gt;&#10;      &lt;CodeBlock code={`Class Order&#10;    - lines : OrderLine[0..*]&#10;    - status : OrderStatus = DRAFT&#10;&#10;    + addItem(item, qty)&#10;        if status is not DRAFT&#10;            refuse - order already placed&#10;        lines.add(a new OrderLine(item, qty))&#10;&#10;    + total() : Money&#10;        sum = ZERO&#10;        for each line in lines&#10;            sum = sum + line.subtotal()&#10;        return sum`} language='text' width={580} fontSize={13} /&gt;&#10;    &lt;/Box&gt;&#10;    &lt;Box style={{ flex: 2, flexDirection: 'column', gap: 11, justifyContent: 'center' }}&gt;&#10;      {[&#10;        ['lock', 'private fields', 'Nobody outside can set status to a nonsense value.'],&#10;        ['user-check', 'guarded method', 'addItem() refuses once the order is placed.'],&#10;        ['calculator', 'computed, not stored', 'total() is derived — there is no stale copy to drift.'],&#10;      ].map(([icon, t, d]) =&gt; (&#10;        &lt;Box key={t} style={{ flexDirection: 'row', gap: 12, alignItems: 'flex-start', padding: '14px 16px', background: '#F7F9FC', borderRadius: 10, border: '1px solid #E5E7EB' }}&gt;&#10;          &lt;Box style={{ width: 38, height: 38, borderRadius: 9, background: '#E8EFF8', justifyContent: 'center', alignItems: 'center' }}&gt;&#10;            &lt;FAIcon name={icon} style={{ fill: '#1E4FA8', width: 19, height: 19 }} /&gt;&#10;          &lt;/Box&gt;&#10;          &lt;Box style={{ flex: 1, flexDirection: 'column', gap: 2 }}&gt;&#10;            &lt;Text style={{ fontSize: 16, fontWeight: 'bold', color: '#0E3F8C' }}&gt;{t}&lt;/Text&gt;&#10;            &lt;Text style={{ fontSize: 14, color: '#4A5568', lineHeight: 1.45 }}&gt;{d}&lt;/Text&gt;&#10;          &lt;/Box&gt;&#10;        &lt;/Box&gt;&#10;      ))}&#10;    &lt;/Box&gt;&#10;  &lt;/Box&gt;&#10;  &lt;Box style={{ height: 40, padding: '0 40px', flexDirection: 'row', alignItems: 'center', justifyContent: 'space-between' }}&gt;&#10;    &lt;Text style={{ fontSize: 13, color: '#8B97A8' }}&gt;Generic types omitted for slide width; your lab code uses List&amp;lt;OrderLine&amp;gt;.&lt;/Text&gt;&#10;    &lt;Text style={{ fontSize: 14, color: '#1E4FA8', fontWeight: 'bold' }}&gt;14 / 38&lt;/Text&gt;&#10;  &lt;/Box&gt;&#10;&lt;/Slide&gt;"/>
         <p:cNvGrpSpPr/>
         <p:nvPr/>
       </p:nvGrpSpPr>
@@ -4572,7 +4572,7 @@
                 <a:latin typeface="Microsoft YaHei"/>
                 <a:ea typeface="Microsoft YaHei"/>
               </a:rPr>
-              <a:t>Encapsulation in Java</a:t>
+              <a:t>Encapsulation on Paper</a:t>
             </a:r>
             <a:endParaRPr/>
           </a:p>
@@ -11954,7 +11954,7 @@
   <p:cSld>
     <p:spTree>
       <p:nvGrpSpPr>
-        <p:cNvPr id="334" name="" descr="&lt;Slide style={{ background: '#FFFFFF', padding: 0 }}&gt;&#10;  &lt;Box style={{ height: 72, background: '#1E4FA8', padding: '0 40px', flexDirection: 'row', alignItems: 'center', justifyContent: 'space-between' }}&gt;&#10;    &lt;Text style={{ fontSize: 15, color: '#B9CDF0', letterSpacing: 1 }}&gt;ISAD · INFORMATION SYSTEMS ANALYSIS &amp;amp; DESIGN&lt;/Text&gt;&#10;    &lt;Text style={{ fontSize: 15, color: '#B9CDF0' }}&gt;W02 · REUSE&lt;/Text&gt;&#10;  &lt;/Box&gt;&#10;  &lt;Box style={{ padding: '20px 40px 0 40px' }}&gt;&#10;    &lt;Text style={{ fontSize: 32, fontWeight: 'bold', color: '#0E3F8C' }}&gt;Composition in Java&lt;/Text&gt;&#10;  &lt;/Box&gt;&#10;  &lt;Box style={{ flex: 1, padding: '14px 40px 0 40px', flexDirection: 'row', gap: 26 }}&gt;&#10;    &lt;Box style={{ flex: 1, flexDirection: 'column', gap: 10 }}&gt;&#10;      &lt;Box style={{ flexDirection: 'row', alignItems: 'center', gap: 9 }}&gt;&#10;        &lt;FAIcon name='times-circle' style={{ fill: '#D9534F', width: 19, height: 19 }} /&gt;&#10;        &lt;Text style={{ fontSize: 16, fontWeight: 'bold', color: '#D9534F' }}&gt;Inheriting for convenience&lt;/Text&gt;&#10;      &lt;/Box&gt;&#10;      &lt;CodeBlock code={`# &quot;an order is just a list of lines&quot;&#10;Class Order extends List&#10;    + place()&#10;&#10;# now Order inherits 20+ list operations&#10;# that make no sense for an order&#10;order.sort(...)&#10;order.clear()      # wipes a paid order&#10;order.addAll(...)  # bypasses the guard`} language='text' width={520} fontSize={12} /&gt;&#10;    &lt;/Box&gt;&#10;    &lt;Box style={{ flex: 1, flexDirection: 'column', gap: 10 }}&gt;&#10;      &lt;Box style={{ flexDirection: 'row', alignItems: 'center', gap: 9 }}&gt;&#10;        &lt;FAIcon name='check-circle' style={{ fill: '#1E4FA8', width: 19, height: 19 }} /&gt;&#10;        &lt;Text style={{ fontSize: 16, fontWeight: 'bold', color: '#0E3F8C' }}&gt;Composing with collaborators&lt;/Text&gt;&#10;      &lt;/Box&gt;&#10;      &lt;CodeBlock code={`Class Order&#10;    - lines : OrderLine[0..*]&#10;    - payment : PaymentMethod&#10;    - route : DeliveryRoute&#10;&#10;    + total() : Money&#10;    + pay() : Receipt&#10;        return payment.pay(total())&#10;&#10;# Order offers only what an order does&#10;order.pay()        # yes&#10;order.clear()      # no such operation`} language='text' width={520} fontSize={12} /&gt;&#10;    &lt;/Box&gt;&#10;  &lt;/Box&gt;&#10;  &lt;Box style={{ height: 44, background: '#0E3F8C', padding: '0 40px', flexDirection: 'row', alignItems: 'center', justifyContent: 'center' }}&gt;&#10;    &lt;Text style={{ fontSize: 17, color: '#FFFFFF', fontWeight: '600' }}&gt;Inheritance reuses everything — including the parts that make no sense. Composition lets you choose.&lt;/Text&gt;&#10;  &lt;/Box&gt;&#10;&lt;/Slide&gt;"/>
+        <p:cNvPr id="334" name="" descr="&lt;Slide style={{ background: '#FFFFFF', padding: 0 }}&gt;&#10;  &lt;Box style={{ height: 72, background: '#1E4FA8', padding: '0 40px', flexDirection: 'row', alignItems: 'center', justifyContent: 'space-between' }}&gt;&#10;    &lt;Text style={{ fontSize: 15, color: '#B9CDF0', letterSpacing: 1 }}&gt;ISAD · INFORMATION SYSTEMS ANALYSIS &amp;amp; DESIGN&lt;/Text&gt;&#10;    &lt;Text style={{ fontSize: 15, color: '#B9CDF0' }}&gt;W02 · REUSE&lt;/Text&gt;&#10;  &lt;/Box&gt;&#10;  &lt;Box style={{ padding: '20px 40px 0 40px' }}&gt;&#10;    &lt;Text style={{ fontSize: 32, fontWeight: 'bold', color: '#0E3F8C' }}&gt;Composition on Paper&lt;/Text&gt;&#10;  &lt;/Box&gt;&#10;  &lt;Box style={{ flex: 1, padding: '14px 40px 0 40px', flexDirection: 'row', gap: 26 }}&gt;&#10;    &lt;Box style={{ flex: 1, flexDirection: 'column', gap: 10 }}&gt;&#10;      &lt;Box style={{ flexDirection: 'row', alignItems: 'center', gap: 9 }}&gt;&#10;        &lt;FAIcon name='times-circle' style={{ fill: '#D9534F', width: 19, height: 19 }} /&gt;&#10;        &lt;Text style={{ fontSize: 16, fontWeight: 'bold', color: '#D9534F' }}&gt;Inheriting for convenience&lt;/Text&gt;&#10;      &lt;/Box&gt;&#10;      &lt;CodeBlock code={`# &quot;an order is just a list of lines&quot;&#10;Class Order extends List&#10;    + place()&#10;&#10;# now Order inherits 20+ list operations&#10;# that make no sense for an order&#10;order.sort(...)&#10;order.clear()      # wipes a paid order&#10;order.addAll(...)  # bypasses the guard`} language='text' width={520} fontSize={12} /&gt;&#10;    &lt;/Box&gt;&#10;    &lt;Box style={{ flex: 1, flexDirection: 'column', gap: 10 }}&gt;&#10;      &lt;Box style={{ flexDirection: 'row', alignItems: 'center', gap: 9 }}&gt;&#10;        &lt;FAIcon name='check-circle' style={{ fill: '#1E4FA8', width: 19, height: 19 }} /&gt;&#10;        &lt;Text style={{ fontSize: 16, fontWeight: 'bold', color: '#0E3F8C' }}&gt;Composing with collaborators&lt;/Text&gt;&#10;      &lt;/Box&gt;&#10;      &lt;CodeBlock code={`Class Order&#10;    - lines : OrderLine[0..*]&#10;    - payment : PaymentMethod&#10;    - route : DeliveryRoute&#10;&#10;    + total() : Money&#10;    + pay() : Receipt&#10;        return payment.pay(total())&#10;&#10;# Order offers only what an order does&#10;order.pay()        # yes&#10;order.clear()      # no such operation`} language='text' width={520} fontSize={12} /&gt;&#10;    &lt;/Box&gt;&#10;  &lt;/Box&gt;&#10;  &lt;Box style={{ height: 44, background: '#0E3F8C', padding: '0 40px', flexDirection: 'row', alignItems: 'center', justifyContent: 'center' }}&gt;&#10;    &lt;Text style={{ fontSize: 17, color: '#FFFFFF', fontWeight: '600' }}&gt;Inheritance reuses everything — including the parts that make no sense. Composition lets you choose.&lt;/Text&gt;&#10;  &lt;/Box&gt;&#10;&lt;/Slide&gt;"/>
         <p:cNvGrpSpPr/>
         <p:nvPr/>
       </p:nvGrpSpPr>
@@ -12113,7 +12113,7 @@
                 <a:latin typeface="Microsoft YaHei"/>
                 <a:ea typeface="Microsoft YaHei"/>
               </a:rPr>
-              <a:t>Composition in Java</a:t>
+              <a:t>Composition on Paper</a:t>
             </a:r>
             <a:endParaRPr/>
           </a:p>
@@ -14029,7 +14029,7 @@
   <p:cSld>
     <p:spTree>
       <p:nvGrpSpPr>
-        <p:cNvPr id="390" name="" descr="&lt;Slide style={{ background: '#FFFFFF', padding: 0 }}&gt;&#10;  &lt;Box style={{ padding: '22px 40px 6px 40px', flexDirection: 'row', alignItems: 'center', justifyContent: 'space-between' }}&gt;&#10;    &lt;Text style={{ fontSize: 33, fontWeight: 'bold', color: '#0E3F8C' }}&gt;PaymentMethod — Polymorphism in Java&lt;/Text&gt;&#10;    &lt;Text style={{ fontSize: 14, color: '#1E4FA8', fontWeight: 'bold' }}&gt;25 / 38&lt;/Text&gt;&#10;  &lt;/Box&gt;&#10;  &lt;Box style={{ flex: 1, padding: '10px 40px 0 40px', flexDirection: 'row', gap: 26 }}&gt;&#10;    &lt;Box style={{ flex: 3, justifyContent: 'center' }}&gt;&#10;      &lt;CodeBlock code={`PaymentMethod (interface)&#10;    + pay(amount) : Receipt&#10;&#10;Class CampusCard implements PaymentMethod&#10;    + pay(amount) : Receipt&#10;        return cardTerminal.deduct(amount)&#10;&#10;Class Wallet implements PaymentMethod&#10;    + pay(amount) : Receipt&#10;        return balance.debit(amount)&#10;&#10;Class Cash implements PaymentMethod&#10;    + pay(amount) : Receipt&#10;        return Receipt.payOnDelivery(amount)&#10;&#10;# the call site - one stable line&#10;r = method.pay(order.total())`} language='text' width={580} fontSize={11} /&gt;&#10;    &lt;/Box&gt;&#10;    &lt;Box style={{ flex: 2, flexDirection: 'column', gap: 12, justifyContent: 'center' }}&gt;&#10;      &lt;Box style={{ padding: '20px 22px', background: '#0E3F8C', borderRadius: 12, flexDirection: 'column', gap: 12 }}&gt;&#10;        &lt;Text style={{ fontSize: 16, color: '#7FA2D6', letterSpacing: 1 }}&gt;THE ONE LINE THAT MATTERS&lt;/Text&gt;&#10;        &lt;Text style={{ fontSize: 17, color: '#FFFFFF', lineHeight: 1.4, fontWeight: 'bold' }}&gt;method.pay(order.total())&lt;/Text&gt;&#10;        &lt;Box style={{ width: 44, height: 4, background: '#FFC107' }} /&gt;&#10;        &lt;Text style={{ fontSize: 15, color: '#C5D4EA', lineHeight: 1.5 }}&gt;It does not say which payment type. It does not need to. Adding a fourth method changes nothing here.&lt;/Text&gt;&#10;      &lt;/Box&gt;&#10;      &lt;Box style={{ padding: '14px 17px', background: '#F0F5FC', borderRadius: 10, border: '1px solid #3D7BD9' }}&gt;&#10;        &lt;Text style={{ fontSize: 15, color: '#4A5568', lineHeight: 1.5 }}&gt;&lt;Text style={{ fontWeight: 'bold', color: '#0E3F8C' }}&gt;The interface is the contract.&lt;/Text&gt; Each class decides how to honour it.&lt;/Text&gt;&#10;      &lt;/Box&gt;&#10;      &lt;Box style={{ padding: '14px 17px', background: '#FDF3F3', borderRadius: 10, borderLeft: '4px solid #D9534F' }}&gt;&#10;        &lt;Text style={{ fontSize: 15, color: '#4A5568', lineHeight: 1.5 }}&gt;No &lt;Text style={{ fontWeight: 'bold', color: '#D9534F' }}&gt;if&lt;/Text&gt; and no &lt;Text style={{ fontWeight: 'bold', color: '#D9534F' }}&gt;switch&lt;/Text&gt; anywhere in Order.&lt;/Text&gt;&#10;      &lt;/Box&gt;&#10;    &lt;/Box&gt;&#10;  &lt;/Box&gt;&#10;  &lt;Box style={{ height: 44, background: '#0E3F8C', padding: '0 40px', flexDirection: 'row', alignItems: 'center', justifyContent: 'center' }}&gt;&#10;    &lt;Text style={{ fontSize: 17, color: '#FFFFFF', fontWeight: '600' }}&gt;CampusBites uses this exact shape. Your M1 models will too.&lt;/Text&gt;&#10;  &lt;/Box&gt;&#10;&lt;/Slide&gt;"/>
+        <p:cNvPr id="390" name="" descr="&lt;Slide style={{ background: '#FFFFFF', padding: 0 }}&gt;&#10;  &lt;Box style={{ padding: '22px 40px 6px 40px', flexDirection: 'row', alignItems: 'center', justifyContent: 'space-between' }}&gt;&#10;    &lt;Text style={{ fontSize: 33, fontWeight: 'bold', color: '#0E3F8C' }}&gt;PaymentMethod — Polymorphism on Paper&lt;/Text&gt;&#10;    &lt;Text style={{ fontSize: 14, color: '#1E4FA8', fontWeight: 'bold' }}&gt;25 / 38&lt;/Text&gt;&#10;  &lt;/Box&gt;&#10;  &lt;Box style={{ flex: 1, padding: '10px 40px 0 40px', flexDirection: 'row', gap: 26 }}&gt;&#10;    &lt;Box style={{ flex: 3, justifyContent: 'center' }}&gt;&#10;      &lt;CodeBlock code={`PaymentMethod (interface)&#10;    + pay(amount) : Receipt&#10;&#10;Class CampusCard implements PaymentMethod&#10;    + pay(amount) : Receipt&#10;        return cardTerminal.deduct(amount)&#10;&#10;Class Wallet implements PaymentMethod&#10;    + pay(amount) : Receipt&#10;        return balance.debit(amount)&#10;&#10;Class Cash implements PaymentMethod&#10;    + pay(amount) : Receipt&#10;        return Receipt.payOnDelivery(amount)&#10;&#10;# the call site - one stable line&#10;r = method.pay(order.total())`} language='text' width={580} fontSize={11} /&gt;&#10;    &lt;/Box&gt;&#10;    &lt;Box style={{ flex: 2, flexDirection: 'column', gap: 12, justifyContent: 'center' }}&gt;&#10;      &lt;Box style={{ padding: '20px 22px', background: '#0E3F8C', borderRadius: 12, flexDirection: 'column', gap: 12 }}&gt;&#10;        &lt;Text style={{ fontSize: 16, color: '#7FA2D6', letterSpacing: 1 }}&gt;THE ONE LINE THAT MATTERS&lt;/Text&gt;&#10;        &lt;Text style={{ fontSize: 17, color: '#FFFFFF', lineHeight: 1.4, fontWeight: 'bold' }}&gt;method.pay(order.total())&lt;/Text&gt;&#10;        &lt;Box style={{ width: 44, height: 4, background: '#FFC107' }} /&gt;&#10;        &lt;Text style={{ fontSize: 15, color: '#C5D4EA', lineHeight: 1.5 }}&gt;It does not say which payment type. It does not need to. Adding a fourth method changes nothing here.&lt;/Text&gt;&#10;      &lt;/Box&gt;&#10;      &lt;Box style={{ padding: '14px 17px', background: '#F0F5FC', borderRadius: 10, border: '1px solid #3D7BD9' }}&gt;&#10;        &lt;Text style={{ fontSize: 15, color: '#4A5568', lineHeight: 1.5 }}&gt;&lt;Text style={{ fontWeight: 'bold', color: '#0E3F8C' }}&gt;The interface is the contract.&lt;/Text&gt; Each class decides how to honour it.&lt;/Text&gt;&#10;      &lt;/Box&gt;&#10;      &lt;Box style={{ padding: '14px 17px', background: '#FDF3F3', borderRadius: 10, borderLeft: '4px solid #D9534F' }}&gt;&#10;        &lt;Text style={{ fontSize: 15, color: '#4A5568', lineHeight: 1.5 }}&gt;No &lt;Text style={{ fontWeight: 'bold', color: '#D9534F' }}&gt;if&lt;/Text&gt; and no &lt;Text style={{ fontWeight: 'bold', color: '#D9534F' }}&gt;switch&lt;/Text&gt; anywhere in Order.&lt;/Text&gt;&#10;      &lt;/Box&gt;&#10;    &lt;/Box&gt;&#10;  &lt;/Box&gt;&#10;  &lt;Box style={{ height: 44, background: '#0E3F8C', padding: '0 40px', flexDirection: 'row', alignItems: 'center', justifyContent: 'center' }}&gt;&#10;    &lt;Text style={{ fontSize: 17, color: '#FFFFFF', fontWeight: '600' }}&gt;CampusBites uses this exact shape. Your M1 models will too.&lt;/Text&gt;&#10;  &lt;/Box&gt;&#10;&lt;/Slide&gt;"/>
         <p:cNvGrpSpPr/>
         <p:nvPr/>
       </p:nvGrpSpPr>
@@ -14074,7 +14074,7 @@
         <p:spPr>
           <a:xfrm rot="0" flipH="0" flipV="0">
             <a:off x="381000" y="209550"/>
-            <a:ext cx="6257925" cy="381000"/>
+            <a:ext cx="6534150" cy="381000"/>
           </a:xfrm>
           <a:prstGeom prst="rect"/>
         </p:spPr>
@@ -14094,7 +14094,7 @@
                 <a:latin typeface="Microsoft YaHei"/>
                 <a:ea typeface="Microsoft YaHei"/>
               </a:rPr>
-              <a:t>PaymentMethod — Polymorphism in Java</a:t>
+              <a:t>PaymentMethod — Polymorphism on Paper</a:t>
             </a:r>
             <a:endParaRPr/>
           </a:p>

</xml_diff>